<commit_message>
Troca o bege por branco: fundo branco e cartões em escala neutra
O fundo dos slides sai do gelo #F8F7F2 para branco puro. Como cartão branco
sobre fundo branco desapareceria, a alternância dos cartões desce um degrau
e passa a ser cinza claro #FAFAF9 / cinza médio #EFEFED — antes era branco /
bege-esverdeado #EDEDDD.

Hairline, filetes e o cinza do corpo de texto perdem a componente amarela
para não destoarem do branco. A textura de papel da capa, do sumário e dos
divisores é neutra (média #EAEAEA) e permanece.

Co-Authored-By: Claude Opus 5 <noreply@anthropic.com>
Claude-Session: https://claude.ai/code/session_01YYZ2VP8ai2jjcg3y8uarku
</commit_message>
<xml_diff>
--- a/Revelacao-de-Essencia-Flavia-Pereira-Muccelin.pptx
+++ b/Revelacao-de-Essencia-Flavia-Pereira-Muccelin.pptx
@@ -3475,7 +3475,7 @@
     <p:bg>
       <p:bgPr>
         <a:solidFill>
-          <a:srgbClr val="F6F5F0"/>
+          <a:srgbClr val="FFFFFF"/>
         </a:solidFill>
         <a:effectLst/>
       </p:bgPr>
@@ -3930,7 +3930,7 @@
     <p:bg>
       <p:bgPr>
         <a:solidFill>
-          <a:srgbClr val="F8F7F2"/>
+          <a:srgbClr val="FFFFFF"/>
         </a:solidFill>
         <a:effectLst/>
       </p:bgPr>
@@ -3999,7 +3999,7 @@
             <a:r>
               <a:rPr sz="1700" b="1" i="0" spc="120">
                 <a:solidFill>
-                  <a:srgbClr val="B5B5AD"/>
+                  <a:srgbClr val="AEAEAA"/>
                 </a:solidFill>
                 <a:latin typeface="Outfit 1 Bold"/>
               </a:rPr>
@@ -4155,7 +4155,7 @@
             <a:r>
               <a:rPr sz="2700" b="0" i="0">
                 <a:solidFill>
-                  <a:srgbClr val="B5B5AD"/>
+                  <a:srgbClr val="AEAEAA"/>
                 </a:solidFill>
                 <a:latin typeface="Outfit 1"/>
               </a:rPr>
@@ -4508,7 +4508,7 @@
     <p:bg>
       <p:bgPr>
         <a:solidFill>
-          <a:srgbClr val="F8F7F2"/>
+          <a:srgbClr val="FFFFFF"/>
         </a:solidFill>
         <a:effectLst/>
       </p:bgPr>
@@ -4550,7 +4550,7 @@
             <a:r>
               <a:rPr sz="1700" b="1" i="0" spc="120">
                 <a:solidFill>
-                  <a:srgbClr val="B5B5AD"/>
+                  <a:srgbClr val="AEAEAA"/>
                 </a:solidFill>
                 <a:latin typeface="Outfit 1 Bold"/>
               </a:rPr>
@@ -4642,7 +4642,7 @@
             </a:avLst>
           </a:prstGeom>
           <a:solidFill>
-            <a:srgbClr val="DCDBD5"/>
+            <a:srgbClr val="DBDBD9"/>
           </a:solidFill>
           <a:ln>
             <a:noFill/>
@@ -4686,7 +4686,7 @@
             <a:avLst/>
           </a:prstGeom>
           <a:solidFill>
-            <a:srgbClr val="E5E4DF"/>
+            <a:srgbClr val="E3E3E1"/>
           </a:solidFill>
           <a:ln>
             <a:noFill/>
@@ -4823,7 +4823,7 @@
             <a:r>
               <a:rPr sz="2500" b="0" i="0">
                 <a:solidFill>
-                  <a:srgbClr val="B5B5AD"/>
+                  <a:srgbClr val="AEAEAA"/>
                 </a:solidFill>
                 <a:latin typeface="Outfit 1"/>
               </a:rPr>
@@ -4847,7 +4847,7 @@
             <a:avLst/>
           </a:prstGeom>
           <a:solidFill>
-            <a:srgbClr val="E5E4DF"/>
+            <a:srgbClr val="E3E3E1"/>
           </a:solidFill>
           <a:ln>
             <a:noFill/>
@@ -4984,7 +4984,7 @@
             <a:r>
               <a:rPr sz="2500" b="0" i="0">
                 <a:solidFill>
-                  <a:srgbClr val="B5B5AD"/>
+                  <a:srgbClr val="AEAEAA"/>
                 </a:solidFill>
                 <a:latin typeface="Outfit 1"/>
               </a:rPr>
@@ -5008,7 +5008,7 @@
             <a:avLst/>
           </a:prstGeom>
           <a:solidFill>
-            <a:srgbClr val="E5E4DF"/>
+            <a:srgbClr val="E3E3E1"/>
           </a:solidFill>
           <a:ln>
             <a:noFill/>
@@ -5145,7 +5145,7 @@
             <a:r>
               <a:rPr sz="2500" b="0" i="0">
                 <a:solidFill>
-                  <a:srgbClr val="B5B5AD"/>
+                  <a:srgbClr val="AEAEAA"/>
                 </a:solidFill>
                 <a:latin typeface="Outfit 1"/>
               </a:rPr>
@@ -5306,7 +5306,7 @@
             <a:r>
               <a:rPr sz="2500" b="0" i="0">
                 <a:solidFill>
-                  <a:srgbClr val="B5B5AD"/>
+                  <a:srgbClr val="AEAEAA"/>
                 </a:solidFill>
                 <a:latin typeface="Outfit 1"/>
               </a:rPr>
@@ -5410,7 +5410,7 @@
     <p:bg>
       <p:bgPr>
         <a:solidFill>
-          <a:srgbClr val="F8F7F2"/>
+          <a:srgbClr val="FFFFFF"/>
         </a:solidFill>
         <a:effectLst/>
       </p:bgPr>
@@ -5452,7 +5452,7 @@
             <a:r>
               <a:rPr sz="1700" b="1" i="0" spc="120">
                 <a:solidFill>
-                  <a:srgbClr val="B5B5AD"/>
+                  <a:srgbClr val="AEAEAA"/>
                 </a:solidFill>
                 <a:latin typeface="Outfit 1 Bold"/>
               </a:rPr>
@@ -5517,7 +5517,7 @@
             </a:avLst>
           </a:prstGeom>
           <a:solidFill>
-            <a:srgbClr val="FFFFFF"/>
+            <a:srgbClr val="FAFAF9"/>
           </a:solidFill>
           <a:ln>
             <a:noFill/>
@@ -5661,7 +5661,7 @@
             <a:r>
               <a:rPr sz="2400" b="0" i="1">
                 <a:solidFill>
-                  <a:srgbClr val="B5B5AD"/>
+                  <a:srgbClr val="AEAEAA"/>
                 </a:solidFill>
                 <a:latin typeface="Outfit 1"/>
               </a:rPr>
@@ -5770,7 +5770,7 @@
             </a:avLst>
           </a:prstGeom>
           <a:solidFill>
-            <a:srgbClr val="EDEDDD"/>
+            <a:srgbClr val="EFEFED"/>
           </a:solidFill>
           <a:ln>
             <a:noFill/>
@@ -5914,7 +5914,7 @@
             <a:r>
               <a:rPr sz="2400" b="0" i="1">
                 <a:solidFill>
-                  <a:srgbClr val="B5B5AD"/>
+                  <a:srgbClr val="AEAEAA"/>
                 </a:solidFill>
                 <a:latin typeface="Outfit 1"/>
               </a:rPr>
@@ -6023,7 +6023,7 @@
             </a:avLst>
           </a:prstGeom>
           <a:solidFill>
-            <a:srgbClr val="FFFFFF"/>
+            <a:srgbClr val="FAFAF9"/>
           </a:solidFill>
           <a:ln>
             <a:noFill/>
@@ -6167,7 +6167,7 @@
             <a:r>
               <a:rPr sz="2400" b="0" i="1">
                 <a:solidFill>
-                  <a:srgbClr val="B5B5AD"/>
+                  <a:srgbClr val="AEAEAA"/>
                 </a:solidFill>
                 <a:latin typeface="Outfit 1"/>
               </a:rPr>
@@ -6276,7 +6276,7 @@
             </a:avLst>
           </a:prstGeom>
           <a:solidFill>
-            <a:srgbClr val="EDEDDD"/>
+            <a:srgbClr val="EFEFED"/>
           </a:solidFill>
           <a:ln>
             <a:noFill/>
@@ -6420,7 +6420,7 @@
             <a:r>
               <a:rPr sz="2400" b="0" i="1">
                 <a:solidFill>
-                  <a:srgbClr val="B5B5AD"/>
+                  <a:srgbClr val="AEAEAA"/>
                 </a:solidFill>
                 <a:latin typeface="Outfit 1"/>
               </a:rPr>
@@ -6607,7 +6607,7 @@
     <p:bg>
       <p:bgPr>
         <a:solidFill>
-          <a:srgbClr val="F8F7F2"/>
+          <a:srgbClr val="FFFFFF"/>
         </a:solidFill>
         <a:effectLst/>
       </p:bgPr>
@@ -6649,7 +6649,7 @@
             <a:r>
               <a:rPr sz="1700" b="1" i="0" spc="120">
                 <a:solidFill>
-                  <a:srgbClr val="B5B5AD"/>
+                  <a:srgbClr val="AEAEAA"/>
                 </a:solidFill>
                 <a:latin typeface="Outfit 1 Bold"/>
               </a:rPr>
@@ -6714,7 +6714,7 @@
             </a:avLst>
           </a:prstGeom>
           <a:solidFill>
-            <a:srgbClr val="E5E4DF"/>
+            <a:srgbClr val="E3E3E1"/>
           </a:solidFill>
           <a:ln>
             <a:noFill/>
@@ -6760,7 +6760,7 @@
             </a:avLst>
           </a:prstGeom>
           <a:solidFill>
-            <a:srgbClr val="FFFFFF"/>
+            <a:srgbClr val="FAFAF9"/>
           </a:solidFill>
           <a:ln>
             <a:noFill/>
@@ -6804,7 +6804,7 @@
             <a:avLst/>
           </a:prstGeom>
           <a:solidFill>
-            <a:srgbClr val="E5E4DF"/>
+            <a:srgbClr val="E3E3E1"/>
           </a:solidFill>
           <a:ln>
             <a:noFill/>
@@ -6941,7 +6941,7 @@
             <a:r>
               <a:rPr sz="2400" b="0" i="0">
                 <a:solidFill>
-                  <a:srgbClr val="B5B5AD"/>
+                  <a:srgbClr val="AEAEAA"/>
                 </a:solidFill>
                 <a:latin typeface="Outfit 1"/>
               </a:rPr>
@@ -7011,7 +7011,7 @@
             </a:avLst>
           </a:prstGeom>
           <a:solidFill>
-            <a:srgbClr val="E5E4DF"/>
+            <a:srgbClr val="E3E3E1"/>
           </a:solidFill>
           <a:ln>
             <a:noFill/>
@@ -7057,7 +7057,7 @@
             </a:avLst>
           </a:prstGeom>
           <a:solidFill>
-            <a:srgbClr val="EDEDDD"/>
+            <a:srgbClr val="EFEFED"/>
           </a:solidFill>
           <a:ln>
             <a:noFill/>
@@ -7101,7 +7101,7 @@
             <a:avLst/>
           </a:prstGeom>
           <a:solidFill>
-            <a:srgbClr val="E5E4DF"/>
+            <a:srgbClr val="E3E3E1"/>
           </a:solidFill>
           <a:ln>
             <a:noFill/>
@@ -7238,7 +7238,7 @@
             <a:r>
               <a:rPr sz="2400" b="0" i="0">
                 <a:solidFill>
-                  <a:srgbClr val="B5B5AD"/>
+                  <a:srgbClr val="AEAEAA"/>
                 </a:solidFill>
                 <a:latin typeface="Outfit 1"/>
               </a:rPr>
@@ -7308,7 +7308,7 @@
             </a:avLst>
           </a:prstGeom>
           <a:solidFill>
-            <a:srgbClr val="E5E4DF"/>
+            <a:srgbClr val="E3E3E1"/>
           </a:solidFill>
           <a:ln>
             <a:noFill/>
@@ -7354,7 +7354,7 @@
             </a:avLst>
           </a:prstGeom>
           <a:solidFill>
-            <a:srgbClr val="FFFFFF"/>
+            <a:srgbClr val="FAFAF9"/>
           </a:solidFill>
           <a:ln>
             <a:noFill/>
@@ -7398,7 +7398,7 @@
             <a:avLst/>
           </a:prstGeom>
           <a:solidFill>
-            <a:srgbClr val="E5E4DF"/>
+            <a:srgbClr val="E3E3E1"/>
           </a:solidFill>
           <a:ln>
             <a:noFill/>
@@ -7535,7 +7535,7 @@
             <a:r>
               <a:rPr sz="2400" b="0" i="0">
                 <a:solidFill>
-                  <a:srgbClr val="B5B5AD"/>
+                  <a:srgbClr val="AEAEAA"/>
                 </a:solidFill>
                 <a:latin typeface="Outfit 1"/>
               </a:rPr>
@@ -7605,7 +7605,7 @@
             </a:avLst>
           </a:prstGeom>
           <a:solidFill>
-            <a:srgbClr val="E5E4DF"/>
+            <a:srgbClr val="E3E3E1"/>
           </a:solidFill>
           <a:ln>
             <a:noFill/>
@@ -7651,7 +7651,7 @@
             </a:avLst>
           </a:prstGeom>
           <a:solidFill>
-            <a:srgbClr val="EDEDDD"/>
+            <a:srgbClr val="EFEFED"/>
           </a:solidFill>
           <a:ln>
             <a:noFill/>
@@ -7832,7 +7832,7 @@
             <a:r>
               <a:rPr sz="2400" b="0" i="0">
                 <a:solidFill>
-                  <a:srgbClr val="B5B5AD"/>
+                  <a:srgbClr val="AEAEAA"/>
                 </a:solidFill>
                 <a:latin typeface="Outfit 1"/>
               </a:rPr>
@@ -7936,7 +7936,7 @@
     <p:bg>
       <p:bgPr>
         <a:solidFill>
-          <a:srgbClr val="F8F7F2"/>
+          <a:srgbClr val="FFFFFF"/>
         </a:solidFill>
         <a:effectLst/>
       </p:bgPr>
@@ -7978,7 +7978,7 @@
             <a:r>
               <a:rPr sz="1700" b="1" i="0" spc="120">
                 <a:solidFill>
-                  <a:srgbClr val="B5B5AD"/>
+                  <a:srgbClr val="AEAEAA"/>
                 </a:solidFill>
                 <a:latin typeface="Outfit 1 Bold"/>
               </a:rPr>
@@ -8070,7 +8070,7 @@
             </a:avLst>
           </a:prstGeom>
           <a:solidFill>
-            <a:srgbClr val="E5E4DF"/>
+            <a:srgbClr val="E3E3E1"/>
           </a:solidFill>
           <a:ln>
             <a:noFill/>
@@ -8116,7 +8116,7 @@
             </a:avLst>
           </a:prstGeom>
           <a:solidFill>
-            <a:srgbClr val="FFFFFF"/>
+            <a:srgbClr val="FAFAF9"/>
           </a:solidFill>
           <a:ln>
             <a:noFill/>
@@ -8260,7 +8260,7 @@
             <a:r>
               <a:rPr sz="2400" b="0" i="0">
                 <a:solidFill>
-                  <a:srgbClr val="B5B5AD"/>
+                  <a:srgbClr val="AEAEAA"/>
                 </a:solidFill>
                 <a:latin typeface="Outfit 1"/>
               </a:rPr>
@@ -8286,7 +8286,7 @@
             </a:avLst>
           </a:prstGeom>
           <a:solidFill>
-            <a:srgbClr val="E5E4DF"/>
+            <a:srgbClr val="E3E3E1"/>
           </a:solidFill>
           <a:ln>
             <a:noFill/>
@@ -8332,7 +8332,7 @@
             </a:avLst>
           </a:prstGeom>
           <a:solidFill>
-            <a:srgbClr val="EDEDDD"/>
+            <a:srgbClr val="EFEFED"/>
           </a:solidFill>
           <a:ln>
             <a:noFill/>
@@ -8476,7 +8476,7 @@
             <a:r>
               <a:rPr sz="2400" b="0" i="0">
                 <a:solidFill>
-                  <a:srgbClr val="B5B5AD"/>
+                  <a:srgbClr val="AEAEAA"/>
                 </a:solidFill>
                 <a:latin typeface="Outfit 1"/>
               </a:rPr>
@@ -8502,7 +8502,7 @@
             </a:avLst>
           </a:prstGeom>
           <a:solidFill>
-            <a:srgbClr val="E5E4DF"/>
+            <a:srgbClr val="E3E3E1"/>
           </a:solidFill>
           <a:ln>
             <a:noFill/>
@@ -8548,7 +8548,7 @@
             </a:avLst>
           </a:prstGeom>
           <a:solidFill>
-            <a:srgbClr val="FFFFFF"/>
+            <a:srgbClr val="FAFAF9"/>
           </a:solidFill>
           <a:ln>
             <a:noFill/>
@@ -8692,7 +8692,7 @@
             <a:r>
               <a:rPr sz="2400" b="0" i="0">
                 <a:solidFill>
-                  <a:srgbClr val="B5B5AD"/>
+                  <a:srgbClr val="AEAEAA"/>
                 </a:solidFill>
                 <a:latin typeface="Outfit 1"/>
               </a:rPr>
@@ -8718,7 +8718,7 @@
             </a:avLst>
           </a:prstGeom>
           <a:solidFill>
-            <a:srgbClr val="E5E4DF"/>
+            <a:srgbClr val="E3E3E1"/>
           </a:solidFill>
           <a:ln>
             <a:noFill/>
@@ -8764,7 +8764,7 @@
             </a:avLst>
           </a:prstGeom>
           <a:solidFill>
-            <a:srgbClr val="EDEDDD"/>
+            <a:srgbClr val="EFEFED"/>
           </a:solidFill>
           <a:ln>
             <a:noFill/>
@@ -8908,7 +8908,7 @@
             <a:r>
               <a:rPr sz="2400" b="0" i="0">
                 <a:solidFill>
-                  <a:srgbClr val="B5B5AD"/>
+                  <a:srgbClr val="AEAEAA"/>
                 </a:solidFill>
                 <a:latin typeface="Outfit 1"/>
               </a:rPr>
@@ -9115,7 +9115,7 @@
     <p:bg>
       <p:bgPr>
         <a:solidFill>
-          <a:srgbClr val="F8F7F2"/>
+          <a:srgbClr val="FFFFFF"/>
         </a:solidFill>
         <a:effectLst/>
       </p:bgPr>
@@ -9157,7 +9157,7 @@
             <a:r>
               <a:rPr sz="1700" b="1" i="0" spc="120">
                 <a:solidFill>
-                  <a:srgbClr val="B5B5AD"/>
+                  <a:srgbClr val="AEAEAA"/>
                 </a:solidFill>
                 <a:latin typeface="Outfit 1 Bold"/>
               </a:rPr>
@@ -9222,7 +9222,7 @@
             </a:avLst>
           </a:prstGeom>
           <a:solidFill>
-            <a:srgbClr val="E5E4DF"/>
+            <a:srgbClr val="E3E3E1"/>
           </a:solidFill>
           <a:ln>
             <a:noFill/>
@@ -9268,7 +9268,7 @@
             </a:avLst>
           </a:prstGeom>
           <a:solidFill>
-            <a:srgbClr val="FFFFFF"/>
+            <a:srgbClr val="FAFAF9"/>
           </a:solidFill>
           <a:ln>
             <a:noFill/>
@@ -9459,7 +9459,7 @@
             </a:avLst>
           </a:prstGeom>
           <a:solidFill>
-            <a:srgbClr val="E5E4DF"/>
+            <a:srgbClr val="E3E3E1"/>
           </a:solidFill>
           <a:ln>
             <a:noFill/>
@@ -9505,7 +9505,7 @@
             </a:avLst>
           </a:prstGeom>
           <a:solidFill>
-            <a:srgbClr val="EDEDDD"/>
+            <a:srgbClr val="EFEFED"/>
           </a:solidFill>
           <a:ln>
             <a:noFill/>
@@ -9696,7 +9696,7 @@
             </a:avLst>
           </a:prstGeom>
           <a:solidFill>
-            <a:srgbClr val="E5E4DF"/>
+            <a:srgbClr val="E3E3E1"/>
           </a:solidFill>
           <a:ln>
             <a:noFill/>
@@ -9742,7 +9742,7 @@
             </a:avLst>
           </a:prstGeom>
           <a:solidFill>
-            <a:srgbClr val="FFFFFF"/>
+            <a:srgbClr val="FAFAF9"/>
           </a:solidFill>
           <a:ln>
             <a:noFill/>
@@ -9933,7 +9933,7 @@
             </a:avLst>
           </a:prstGeom>
           <a:solidFill>
-            <a:srgbClr val="E5E4DF"/>
+            <a:srgbClr val="E3E3E1"/>
           </a:solidFill>
           <a:ln>
             <a:noFill/>
@@ -9979,7 +9979,7 @@
             </a:avLst>
           </a:prstGeom>
           <a:solidFill>
-            <a:srgbClr val="EDEDDD"/>
+            <a:srgbClr val="EFEFED"/>
           </a:solidFill>
           <a:ln>
             <a:noFill/>
@@ -10170,7 +10170,7 @@
             </a:avLst>
           </a:prstGeom>
           <a:solidFill>
-            <a:srgbClr val="E5E4DF"/>
+            <a:srgbClr val="E3E3E1"/>
           </a:solidFill>
           <a:ln>
             <a:noFill/>
@@ -10216,7 +10216,7 @@
             </a:avLst>
           </a:prstGeom>
           <a:solidFill>
-            <a:srgbClr val="FFFFFF"/>
+            <a:srgbClr val="FAFAF9"/>
           </a:solidFill>
           <a:ln>
             <a:noFill/>
@@ -10673,7 +10673,7 @@
     <p:bg>
       <p:bgPr>
         <a:solidFill>
-          <a:srgbClr val="F6F5F0"/>
+          <a:srgbClr val="FFFFFF"/>
         </a:solidFill>
         <a:effectLst/>
       </p:bgPr>
@@ -10898,7 +10898,7 @@
     <p:bg>
       <p:bgPr>
         <a:solidFill>
-          <a:srgbClr val="F8F7F2"/>
+          <a:srgbClr val="FFFFFF"/>
         </a:solidFill>
         <a:effectLst/>
       </p:bgPr>
@@ -10964,7 +10964,7 @@
             <a:r>
               <a:rPr sz="1700" b="1" i="0" spc="120">
                 <a:solidFill>
-                  <a:srgbClr val="B5B5AD"/>
+                  <a:srgbClr val="AEAEAA"/>
                 </a:solidFill>
                 <a:latin typeface="Outfit 1 Bold"/>
               </a:rPr>
@@ -11003,7 +11003,7 @@
             <a:r>
               <a:rPr sz="3000" b="0" i="0">
                 <a:solidFill>
-                  <a:srgbClr val="B5B5AD"/>
+                  <a:srgbClr val="AEAEAA"/>
                 </a:solidFill>
                 <a:latin typeface="Outfit 1"/>
               </a:rPr>
@@ -11224,7 +11224,7 @@
     <p:bg>
       <p:bgPr>
         <a:solidFill>
-          <a:srgbClr val="F6F5F0"/>
+          <a:srgbClr val="FFFFFF"/>
         </a:solidFill>
         <a:effectLst/>
       </p:bgPr>
@@ -11433,7 +11433,7 @@
     <p:bg>
       <p:bgPr>
         <a:solidFill>
-          <a:srgbClr val="F8F7F2"/>
+          <a:srgbClr val="FFFFFF"/>
         </a:solidFill>
         <a:effectLst/>
       </p:bgPr>
@@ -11475,7 +11475,7 @@
             <a:r>
               <a:rPr sz="1700" b="1" i="0" spc="120">
                 <a:solidFill>
-                  <a:srgbClr val="B5B5AD"/>
+                  <a:srgbClr val="AEAEAA"/>
                 </a:solidFill>
                 <a:latin typeface="Outfit 1 Bold"/>
               </a:rPr>
@@ -11629,7 +11629,7 @@
             </a:avLst>
           </a:prstGeom>
           <a:solidFill>
-            <a:srgbClr val="E5E4DF"/>
+            <a:srgbClr val="E3E3E1"/>
           </a:solidFill>
           <a:ln>
             <a:noFill/>
@@ -11675,7 +11675,7 @@
             </a:avLst>
           </a:prstGeom>
           <a:solidFill>
-            <a:srgbClr val="FFFFFF"/>
+            <a:srgbClr val="FAFAF9"/>
           </a:solidFill>
           <a:ln>
             <a:noFill/>
@@ -11780,7 +11780,7 @@
             <a:r>
               <a:rPr sz="2700" b="0" i="0">
                 <a:solidFill>
-                  <a:srgbClr val="B5B5AD"/>
+                  <a:srgbClr val="AEAEAA"/>
                 </a:solidFill>
                 <a:latin typeface="Outfit 1"/>
               </a:rPr>
@@ -11923,7 +11923,7 @@
     <p:bg>
       <p:bgPr>
         <a:solidFill>
-          <a:srgbClr val="F6F5F0"/>
+          <a:srgbClr val="FFFFFF"/>
         </a:solidFill>
         <a:effectLst/>
       </p:bgPr>
@@ -12139,7 +12139,7 @@
             </a:avLst>
           </a:prstGeom>
           <a:solidFill>
-            <a:srgbClr val="DCDBD5"/>
+            <a:srgbClr val="DBDBD9"/>
           </a:solidFill>
           <a:ln>
             <a:noFill/>
@@ -12263,7 +12263,7 @@
             </a:avLst>
           </a:prstGeom>
           <a:solidFill>
-            <a:srgbClr val="DCDBD5"/>
+            <a:srgbClr val="DBDBD9"/>
           </a:solidFill>
           <a:ln>
             <a:noFill/>
@@ -12387,7 +12387,7 @@
             </a:avLst>
           </a:prstGeom>
           <a:solidFill>
-            <a:srgbClr val="DCDBD5"/>
+            <a:srgbClr val="DBDBD9"/>
           </a:solidFill>
           <a:ln>
             <a:noFill/>
@@ -12511,7 +12511,7 @@
             </a:avLst>
           </a:prstGeom>
           <a:solidFill>
-            <a:srgbClr val="DCDBD5"/>
+            <a:srgbClr val="DBDBD9"/>
           </a:solidFill>
           <a:ln>
             <a:noFill/>
@@ -12713,7 +12713,7 @@
     <p:bg>
       <p:bgPr>
         <a:solidFill>
-          <a:srgbClr val="F8F7F2"/>
+          <a:srgbClr val="FFFFFF"/>
         </a:solidFill>
         <a:effectLst/>
       </p:bgPr>
@@ -12755,7 +12755,7 @@
             <a:r>
               <a:rPr sz="1700" b="1" i="0" spc="120">
                 <a:solidFill>
-                  <a:srgbClr val="B5B5AD"/>
+                  <a:srgbClr val="AEAEAA"/>
                 </a:solidFill>
                 <a:latin typeface="Outfit 1 Bold"/>
               </a:rPr>
@@ -12847,7 +12847,7 @@
             </a:avLst>
           </a:prstGeom>
           <a:solidFill>
-            <a:srgbClr val="E5E4DF"/>
+            <a:srgbClr val="E3E3E1"/>
           </a:solidFill>
           <a:ln>
             <a:noFill/>
@@ -12893,7 +12893,7 @@
             </a:avLst>
           </a:prstGeom>
           <a:solidFill>
-            <a:srgbClr val="FFFFFF"/>
+            <a:srgbClr val="FAFAF9"/>
           </a:solidFill>
           <a:ln>
             <a:noFill/>
@@ -13037,7 +13037,7 @@
             <a:r>
               <a:rPr sz="2300" b="0" i="0">
                 <a:solidFill>
-                  <a:srgbClr val="B5B5AD"/>
+                  <a:srgbClr val="AEAEAA"/>
                 </a:solidFill>
                 <a:latin typeface="Outfit 1"/>
               </a:rPr>
@@ -13063,7 +13063,7 @@
             </a:avLst>
           </a:prstGeom>
           <a:solidFill>
-            <a:srgbClr val="E5E4DF"/>
+            <a:srgbClr val="E3E3E1"/>
           </a:solidFill>
           <a:ln>
             <a:noFill/>
@@ -13109,7 +13109,7 @@
             </a:avLst>
           </a:prstGeom>
           <a:solidFill>
-            <a:srgbClr val="EDEDDD"/>
+            <a:srgbClr val="EFEFED"/>
           </a:solidFill>
           <a:ln>
             <a:noFill/>
@@ -13253,7 +13253,7 @@
             <a:r>
               <a:rPr sz="2300" b="0" i="0">
                 <a:solidFill>
-                  <a:srgbClr val="B5B5AD"/>
+                  <a:srgbClr val="AEAEAA"/>
                 </a:solidFill>
                 <a:latin typeface="Outfit 1"/>
               </a:rPr>
@@ -13279,7 +13279,7 @@
             </a:avLst>
           </a:prstGeom>
           <a:solidFill>
-            <a:srgbClr val="E5E4DF"/>
+            <a:srgbClr val="E3E3E1"/>
           </a:solidFill>
           <a:ln>
             <a:noFill/>
@@ -13325,7 +13325,7 @@
             </a:avLst>
           </a:prstGeom>
           <a:solidFill>
-            <a:srgbClr val="FFFFFF"/>
+            <a:srgbClr val="FAFAF9"/>
           </a:solidFill>
           <a:ln>
             <a:noFill/>
@@ -13469,7 +13469,7 @@
             <a:r>
               <a:rPr sz="2300" b="0" i="0">
                 <a:solidFill>
-                  <a:srgbClr val="B5B5AD"/>
+                  <a:srgbClr val="AEAEAA"/>
                 </a:solidFill>
                 <a:latin typeface="Outfit 1"/>
               </a:rPr>
@@ -13495,7 +13495,7 @@
             </a:avLst>
           </a:prstGeom>
           <a:solidFill>
-            <a:srgbClr val="E5E4DF"/>
+            <a:srgbClr val="E3E3E1"/>
           </a:solidFill>
           <a:ln>
             <a:noFill/>
@@ -13541,7 +13541,7 @@
             </a:avLst>
           </a:prstGeom>
           <a:solidFill>
-            <a:srgbClr val="EDEDDD"/>
+            <a:srgbClr val="EFEFED"/>
           </a:solidFill>
           <a:ln>
             <a:noFill/>
@@ -13685,7 +13685,7 @@
             <a:r>
               <a:rPr sz="2300" b="0" i="0">
                 <a:solidFill>
-                  <a:srgbClr val="B5B5AD"/>
+                  <a:srgbClr val="AEAEAA"/>
                 </a:solidFill>
                 <a:latin typeface="Outfit 1"/>
               </a:rPr>
@@ -13904,7 +13904,7 @@
     <p:bg>
       <p:bgPr>
         <a:solidFill>
-          <a:srgbClr val="F8F7F2"/>
+          <a:srgbClr val="FFFFFF"/>
         </a:solidFill>
         <a:effectLst/>
       </p:bgPr>
@@ -13946,7 +13946,7 @@
             <a:r>
               <a:rPr sz="1700" b="1" i="0" spc="120">
                 <a:solidFill>
-                  <a:srgbClr val="B5B5AD"/>
+                  <a:srgbClr val="AEAEAA"/>
                 </a:solidFill>
                 <a:latin typeface="Outfit 1 Bold"/>
               </a:rPr>
@@ -14290,7 +14290,7 @@
     <p:bg>
       <p:bgPr>
         <a:solidFill>
-          <a:srgbClr val="F8F7F2"/>
+          <a:srgbClr val="FFFFFF"/>
         </a:solidFill>
         <a:effectLst/>
       </p:bgPr>
@@ -14332,7 +14332,7 @@
             <a:r>
               <a:rPr sz="1700" b="1" i="0" spc="120">
                 <a:solidFill>
-                  <a:srgbClr val="B5B5AD"/>
+                  <a:srgbClr val="AEAEAA"/>
                 </a:solidFill>
                 <a:latin typeface="Outfit 1 Bold"/>
               </a:rPr>
@@ -14397,7 +14397,7 @@
             </a:avLst>
           </a:prstGeom>
           <a:solidFill>
-            <a:srgbClr val="E5E4DF"/>
+            <a:srgbClr val="E3E3E1"/>
           </a:solidFill>
           <a:ln>
             <a:noFill/>
@@ -14443,7 +14443,7 @@
             </a:avLst>
           </a:prstGeom>
           <a:solidFill>
-            <a:srgbClr val="FFFFFF"/>
+            <a:srgbClr val="FAFAF9"/>
           </a:solidFill>
           <a:ln>
             <a:noFill/>
@@ -14587,7 +14587,7 @@
             <a:r>
               <a:rPr sz="2300" b="0" i="0">
                 <a:solidFill>
-                  <a:srgbClr val="B5B5AD"/>
+                  <a:srgbClr val="AEAEAA"/>
                 </a:solidFill>
                 <a:latin typeface="Outfit 1"/>
               </a:rPr>
@@ -14613,7 +14613,7 @@
             </a:avLst>
           </a:prstGeom>
           <a:solidFill>
-            <a:srgbClr val="E5E4DF"/>
+            <a:srgbClr val="E3E3E1"/>
           </a:solidFill>
           <a:ln>
             <a:noFill/>
@@ -14659,7 +14659,7 @@
             </a:avLst>
           </a:prstGeom>
           <a:solidFill>
-            <a:srgbClr val="EDEDDD"/>
+            <a:srgbClr val="EFEFED"/>
           </a:solidFill>
           <a:ln>
             <a:noFill/>
@@ -14803,7 +14803,7 @@
             <a:r>
               <a:rPr sz="2300" b="0" i="0">
                 <a:solidFill>
-                  <a:srgbClr val="B5B5AD"/>
+                  <a:srgbClr val="AEAEAA"/>
                 </a:solidFill>
                 <a:latin typeface="Outfit 1"/>
               </a:rPr>
@@ -14829,7 +14829,7 @@
             </a:avLst>
           </a:prstGeom>
           <a:solidFill>
-            <a:srgbClr val="E5E4DF"/>
+            <a:srgbClr val="E3E3E1"/>
           </a:solidFill>
           <a:ln>
             <a:noFill/>
@@ -14875,7 +14875,7 @@
             </a:avLst>
           </a:prstGeom>
           <a:solidFill>
-            <a:srgbClr val="FFFFFF"/>
+            <a:srgbClr val="FAFAF9"/>
           </a:solidFill>
           <a:ln>
             <a:noFill/>
@@ -15019,7 +15019,7 @@
             <a:r>
               <a:rPr sz="2300" b="0" i="0">
                 <a:solidFill>
-                  <a:srgbClr val="B5B5AD"/>
+                  <a:srgbClr val="AEAEAA"/>
                 </a:solidFill>
                 <a:latin typeface="Outfit 1"/>
               </a:rPr>
@@ -15045,7 +15045,7 @@
             </a:avLst>
           </a:prstGeom>
           <a:solidFill>
-            <a:srgbClr val="E5E4DF"/>
+            <a:srgbClr val="E3E3E1"/>
           </a:solidFill>
           <a:ln>
             <a:noFill/>
@@ -15091,7 +15091,7 @@
             </a:avLst>
           </a:prstGeom>
           <a:solidFill>
-            <a:srgbClr val="EDEDDD"/>
+            <a:srgbClr val="EFEFED"/>
           </a:solidFill>
           <a:ln>
             <a:noFill/>
@@ -15235,7 +15235,7 @@
             <a:r>
               <a:rPr sz="2300" b="0" i="0">
                 <a:solidFill>
-                  <a:srgbClr val="B5B5AD"/>
+                  <a:srgbClr val="AEAEAA"/>
                 </a:solidFill>
                 <a:latin typeface="Outfit 1"/>
               </a:rPr>
@@ -15344,7 +15344,7 @@
             </a:avLst>
           </a:prstGeom>
           <a:solidFill>
-            <a:srgbClr val="DCDBD5"/>
+            <a:srgbClr val="DBDBD9"/>
           </a:solidFill>
           <a:ln>
             <a:noFill/>
@@ -15390,7 +15390,7 @@
             </a:avLst>
           </a:prstGeom>
           <a:solidFill>
-            <a:srgbClr val="DCDBD5"/>
+            <a:srgbClr val="DBDBD9"/>
           </a:solidFill>
           <a:ln>
             <a:noFill/>
@@ -15436,7 +15436,7 @@
             </a:avLst>
           </a:prstGeom>
           <a:solidFill>
-            <a:srgbClr val="DCDBD5"/>
+            <a:srgbClr val="DBDBD9"/>
           </a:solidFill>
           <a:ln>
             <a:noFill/>
@@ -15482,7 +15482,7 @@
             </a:avLst>
           </a:prstGeom>
           <a:solidFill>
-            <a:srgbClr val="DCDBD5"/>
+            <a:srgbClr val="DBDBD9"/>
           </a:solidFill>
           <a:ln>
             <a:noFill/>
@@ -15663,7 +15663,7 @@
     <p:bg>
       <p:bgPr>
         <a:solidFill>
-          <a:srgbClr val="F6F5F0"/>
+          <a:srgbClr val="FFFFFF"/>
         </a:solidFill>
         <a:effectLst/>
       </p:bgPr>
@@ -15872,7 +15872,7 @@
     <p:bg>
       <p:bgPr>
         <a:solidFill>
-          <a:srgbClr val="F8F7F2"/>
+          <a:srgbClr val="FFFFFF"/>
         </a:solidFill>
         <a:effectLst/>
       </p:bgPr>
@@ -15914,7 +15914,7 @@
             <a:r>
               <a:rPr sz="1700" b="1" i="0" spc="120">
                 <a:solidFill>
-                  <a:srgbClr val="B5B5AD"/>
+                  <a:srgbClr val="AEAEAA"/>
                 </a:solidFill>
                 <a:latin typeface="Outfit 1 Bold"/>
               </a:rPr>
@@ -16080,7 +16080,7 @@
             </a:avLst>
           </a:prstGeom>
           <a:solidFill>
-            <a:srgbClr val="E5E4DF"/>
+            <a:srgbClr val="E3E3E1"/>
           </a:solidFill>
           <a:ln>
             <a:noFill/>
@@ -16126,7 +16126,7 @@
             </a:avLst>
           </a:prstGeom>
           <a:solidFill>
-            <a:srgbClr val="FFFFFF"/>
+            <a:srgbClr val="FAFAF9"/>
           </a:solidFill>
           <a:ln>
             <a:noFill/>
@@ -16270,7 +16270,7 @@
             <a:r>
               <a:rPr sz="2500" b="0" i="0">
                 <a:solidFill>
-                  <a:srgbClr val="B5B5AD"/>
+                  <a:srgbClr val="AEAEAA"/>
                 </a:solidFill>
                 <a:latin typeface="Outfit 1"/>
               </a:rPr>
@@ -16296,7 +16296,7 @@
             </a:avLst>
           </a:prstGeom>
           <a:solidFill>
-            <a:srgbClr val="E5E4DF"/>
+            <a:srgbClr val="E3E3E1"/>
           </a:solidFill>
           <a:ln>
             <a:noFill/>
@@ -16342,7 +16342,7 @@
             </a:avLst>
           </a:prstGeom>
           <a:solidFill>
-            <a:srgbClr val="EDEDDD"/>
+            <a:srgbClr val="EFEFED"/>
           </a:solidFill>
           <a:ln>
             <a:noFill/>
@@ -16486,7 +16486,7 @@
             <a:r>
               <a:rPr sz="2500" b="0" i="0">
                 <a:solidFill>
-                  <a:srgbClr val="B5B5AD"/>
+                  <a:srgbClr val="AEAEAA"/>
                 </a:solidFill>
                 <a:latin typeface="Outfit 1"/>
               </a:rPr>
@@ -16512,7 +16512,7 @@
             </a:avLst>
           </a:prstGeom>
           <a:solidFill>
-            <a:srgbClr val="E5E4DF"/>
+            <a:srgbClr val="E3E3E1"/>
           </a:solidFill>
           <a:ln>
             <a:noFill/>
@@ -16558,7 +16558,7 @@
             </a:avLst>
           </a:prstGeom>
           <a:solidFill>
-            <a:srgbClr val="FFFFFF"/>
+            <a:srgbClr val="FAFAF9"/>
           </a:solidFill>
           <a:ln>
             <a:noFill/>
@@ -16702,7 +16702,7 @@
             <a:r>
               <a:rPr sz="2500" b="0" i="0">
                 <a:solidFill>
-                  <a:srgbClr val="B5B5AD"/>
+                  <a:srgbClr val="AEAEAA"/>
                 </a:solidFill>
                 <a:latin typeface="Outfit 1"/>
               </a:rPr>
@@ -16728,7 +16728,7 @@
             </a:avLst>
           </a:prstGeom>
           <a:solidFill>
-            <a:srgbClr val="E5E4DF"/>
+            <a:srgbClr val="E3E3E1"/>
           </a:solidFill>
           <a:ln>
             <a:noFill/>
@@ -16774,7 +16774,7 @@
             </a:avLst>
           </a:prstGeom>
           <a:solidFill>
-            <a:srgbClr val="EDEDDD"/>
+            <a:srgbClr val="EFEFED"/>
           </a:solidFill>
           <a:ln>
             <a:noFill/>
@@ -16918,7 +16918,7 @@
             <a:r>
               <a:rPr sz="2500" b="0" i="0">
                 <a:solidFill>
-                  <a:srgbClr val="B5B5AD"/>
+                  <a:srgbClr val="AEAEAA"/>
                 </a:solidFill>
                 <a:latin typeface="Outfit 1"/>
               </a:rPr>
@@ -17022,7 +17022,7 @@
     <p:bg>
       <p:bgPr>
         <a:solidFill>
-          <a:srgbClr val="F8F7F2"/>
+          <a:srgbClr val="FFFFFF"/>
         </a:solidFill>
         <a:effectLst/>
       </p:bgPr>
@@ -17064,7 +17064,7 @@
             <a:r>
               <a:rPr sz="1700" b="1" i="0" spc="120">
                 <a:solidFill>
-                  <a:srgbClr val="B5B5AD"/>
+                  <a:srgbClr val="AEAEAA"/>
                 </a:solidFill>
                 <a:latin typeface="Outfit 1 Bold"/>
               </a:rPr>
@@ -17287,7 +17287,7 @@
             </a:avLst>
           </a:prstGeom>
           <a:solidFill>
-            <a:srgbClr val="E5E4DF"/>
+            <a:srgbClr val="E3E3E1"/>
           </a:solidFill>
           <a:ln>
             <a:noFill/>
@@ -17333,7 +17333,7 @@
             </a:avLst>
           </a:prstGeom>
           <a:solidFill>
-            <a:srgbClr val="FFFFFF"/>
+            <a:srgbClr val="FAFAF9"/>
           </a:solidFill>
           <a:ln>
             <a:noFill/>
@@ -17516,7 +17516,7 @@
             <a:r>
               <a:rPr sz="2300" b="0" i="0">
                 <a:solidFill>
-                  <a:srgbClr val="B5B5AD"/>
+                  <a:srgbClr val="AEAEAA"/>
                 </a:solidFill>
                 <a:latin typeface="Outfit 1"/>
               </a:rPr>
@@ -17542,7 +17542,7 @@
             </a:avLst>
           </a:prstGeom>
           <a:solidFill>
-            <a:srgbClr val="E5E4DF"/>
+            <a:srgbClr val="E3E3E1"/>
           </a:solidFill>
           <a:ln>
             <a:noFill/>
@@ -17588,7 +17588,7 @@
             </a:avLst>
           </a:prstGeom>
           <a:solidFill>
-            <a:srgbClr val="EDEDDD"/>
+            <a:srgbClr val="EFEFED"/>
           </a:solidFill>
           <a:ln>
             <a:noFill/>
@@ -17771,7 +17771,7 @@
             <a:r>
               <a:rPr sz="2300" b="0" i="0">
                 <a:solidFill>
-                  <a:srgbClr val="B5B5AD"/>
+                  <a:srgbClr val="AEAEAA"/>
                 </a:solidFill>
                 <a:latin typeface="Outfit 1"/>
               </a:rPr>
@@ -17810,7 +17810,7 @@
             <a:r>
               <a:rPr sz="2100" b="0" i="1">
                 <a:solidFill>
-                  <a:srgbClr val="B5B5AD"/>
+                  <a:srgbClr val="AEAEAA"/>
                 </a:solidFill>
                 <a:latin typeface="Outfit 2"/>
               </a:rPr>
@@ -17914,7 +17914,7 @@
     <p:bg>
       <p:bgPr>
         <a:solidFill>
-          <a:srgbClr val="F8F7F2"/>
+          <a:srgbClr val="FFFFFF"/>
         </a:solidFill>
         <a:effectLst/>
       </p:bgPr>
@@ -18002,7 +18002,7 @@
             <a:r>
               <a:rPr sz="1700" b="1" i="0" spc="120">
                 <a:solidFill>
-                  <a:srgbClr val="B5B5AD"/>
+                  <a:srgbClr val="AEAEAA"/>
                 </a:solidFill>
                 <a:latin typeface="Outfit 1 Bold"/>
               </a:rPr>
@@ -18177,7 +18177,7 @@
     <p:bg>
       <p:bgPr>
         <a:solidFill>
-          <a:srgbClr val="F6F5F0"/>
+          <a:srgbClr val="FFFFFF"/>
         </a:solidFill>
         <a:effectLst/>
       </p:bgPr>
@@ -18386,7 +18386,7 @@
     <p:bg>
       <p:bgPr>
         <a:solidFill>
-          <a:srgbClr val="F8F7F2"/>
+          <a:srgbClr val="FFFFFF"/>
         </a:solidFill>
         <a:effectLst/>
       </p:bgPr>
@@ -18428,7 +18428,7 @@
             <a:r>
               <a:rPr sz="1700" b="1" i="0" spc="120">
                 <a:solidFill>
-                  <a:srgbClr val="B5B5AD"/>
+                  <a:srgbClr val="AEAEAA"/>
                 </a:solidFill>
                 <a:latin typeface="Outfit 1 Bold"/>
               </a:rPr>
@@ -18506,7 +18506,7 @@
             <a:r>
               <a:rPr sz="3000" b="0" i="0">
                 <a:solidFill>
-                  <a:srgbClr val="B5B5AD"/>
+                  <a:srgbClr val="AEAEAA"/>
                 </a:solidFill>
                 <a:latin typeface="Outfit 1"/>
               </a:rPr>
@@ -18532,7 +18532,7 @@
             </a:avLst>
           </a:prstGeom>
           <a:solidFill>
-            <a:srgbClr val="E5E4DF"/>
+            <a:srgbClr val="E3E3E1"/>
           </a:solidFill>
           <a:ln>
             <a:noFill/>
@@ -18578,7 +18578,7 @@
             </a:avLst>
           </a:prstGeom>
           <a:solidFill>
-            <a:srgbClr val="FFFFFF"/>
+            <a:srgbClr val="FAFAF9"/>
           </a:solidFill>
           <a:ln>
             <a:noFill/>
@@ -18683,7 +18683,7 @@
             <a:r>
               <a:rPr sz="3000" b="0" i="1">
                 <a:solidFill>
-                  <a:srgbClr val="B5B5AD"/>
+                  <a:srgbClr val="AEAEAA"/>
                 </a:solidFill>
                 <a:latin typeface="Outfit 1"/>
               </a:rPr>
@@ -18890,7 +18890,7 @@
     <p:bg>
       <p:bgPr>
         <a:solidFill>
-          <a:srgbClr val="F8F7F2"/>
+          <a:srgbClr val="FFFFFF"/>
         </a:solidFill>
         <a:effectLst/>
       </p:bgPr>
@@ -18932,7 +18932,7 @@
             <a:r>
               <a:rPr sz="1700" b="1" i="0" spc="120">
                 <a:solidFill>
-                  <a:srgbClr val="B5B5AD"/>
+                  <a:srgbClr val="AEAEAA"/>
                 </a:solidFill>
                 <a:latin typeface="Outfit 1 Bold"/>
               </a:rPr>
@@ -18997,7 +18997,7 @@
             </a:avLst>
           </a:prstGeom>
           <a:solidFill>
-            <a:srgbClr val="E5E4DF"/>
+            <a:srgbClr val="E3E3E1"/>
           </a:solidFill>
           <a:ln>
             <a:noFill/>
@@ -19043,7 +19043,7 @@
             </a:avLst>
           </a:prstGeom>
           <a:solidFill>
-            <a:srgbClr val="FFFFFF"/>
+            <a:srgbClr val="FAFAF9"/>
           </a:solidFill>
           <a:ln>
             <a:noFill/>
@@ -19226,7 +19226,7 @@
             <a:r>
               <a:rPr sz="2500" b="0" i="0">
                 <a:solidFill>
-                  <a:srgbClr val="B5B5AD"/>
+                  <a:srgbClr val="AEAEAA"/>
                 </a:solidFill>
                 <a:latin typeface="Outfit 1"/>
               </a:rPr>
@@ -19252,7 +19252,7 @@
             </a:avLst>
           </a:prstGeom>
           <a:solidFill>
-            <a:srgbClr val="E5E4DF"/>
+            <a:srgbClr val="E3E3E1"/>
           </a:solidFill>
           <a:ln>
             <a:noFill/>
@@ -19298,7 +19298,7 @@
             </a:avLst>
           </a:prstGeom>
           <a:solidFill>
-            <a:srgbClr val="EDEDDD"/>
+            <a:srgbClr val="EFEFED"/>
           </a:solidFill>
           <a:ln>
             <a:noFill/>
@@ -19481,7 +19481,7 @@
             <a:r>
               <a:rPr sz="2500" b="0" i="0">
                 <a:solidFill>
-                  <a:srgbClr val="B5B5AD"/>
+                  <a:srgbClr val="AEAEAA"/>
                 </a:solidFill>
                 <a:latin typeface="Outfit 1"/>
               </a:rPr>
@@ -19507,7 +19507,7 @@
             </a:avLst>
           </a:prstGeom>
           <a:solidFill>
-            <a:srgbClr val="E5E4DF"/>
+            <a:srgbClr val="E3E3E1"/>
           </a:solidFill>
           <a:ln>
             <a:noFill/>
@@ -19553,7 +19553,7 @@
             </a:avLst>
           </a:prstGeom>
           <a:solidFill>
-            <a:srgbClr val="FFFFFF"/>
+            <a:srgbClr val="FAFAF9"/>
           </a:solidFill>
           <a:ln>
             <a:noFill/>
@@ -19736,7 +19736,7 @@
             <a:r>
               <a:rPr sz="2500" b="0" i="0">
                 <a:solidFill>
-                  <a:srgbClr val="B5B5AD"/>
+                  <a:srgbClr val="AEAEAA"/>
                 </a:solidFill>
                 <a:latin typeface="Outfit 1"/>
               </a:rPr>
@@ -19762,7 +19762,7 @@
             </a:avLst>
           </a:prstGeom>
           <a:solidFill>
-            <a:srgbClr val="E5E4DF"/>
+            <a:srgbClr val="E3E3E1"/>
           </a:solidFill>
           <a:ln>
             <a:noFill/>
@@ -19808,7 +19808,7 @@
             </a:avLst>
           </a:prstGeom>
           <a:solidFill>
-            <a:srgbClr val="EDEDDD"/>
+            <a:srgbClr val="EFEFED"/>
           </a:solidFill>
           <a:ln>
             <a:noFill/>
@@ -19991,7 +19991,7 @@
             <a:r>
               <a:rPr sz="2500" b="0" i="0">
                 <a:solidFill>
-                  <a:srgbClr val="B5B5AD"/>
+                  <a:srgbClr val="AEAEAA"/>
                 </a:solidFill>
                 <a:latin typeface="Outfit 1"/>
               </a:rPr>
@@ -20237,7 +20237,7 @@
     <p:bg>
       <p:bgPr>
         <a:solidFill>
-          <a:srgbClr val="F8F7F2"/>
+          <a:srgbClr val="FFFFFF"/>
         </a:solidFill>
         <a:effectLst/>
       </p:bgPr>
@@ -20279,7 +20279,7 @@
             <a:r>
               <a:rPr sz="1700" b="1" i="0" spc="120">
                 <a:solidFill>
-                  <a:srgbClr val="B5B5AD"/>
+                  <a:srgbClr val="AEAEAA"/>
                 </a:solidFill>
                 <a:latin typeface="Outfit 1 Bold"/>
               </a:rPr>
@@ -20344,7 +20344,7 @@
             </a:avLst>
           </a:prstGeom>
           <a:solidFill>
-            <a:srgbClr val="E5E4DF"/>
+            <a:srgbClr val="E3E3E1"/>
           </a:solidFill>
           <a:ln>
             <a:noFill/>
@@ -20390,7 +20390,7 @@
             </a:avLst>
           </a:prstGeom>
           <a:solidFill>
-            <a:srgbClr val="FFFFFF"/>
+            <a:srgbClr val="FAFAF9"/>
           </a:solidFill>
           <a:ln>
             <a:noFill/>
@@ -20519,7 +20519,7 @@
             <a:avLst/>
           </a:prstGeom>
           <a:solidFill>
-            <a:srgbClr val="E5E4DF"/>
+            <a:srgbClr val="E3E3E1"/>
           </a:solidFill>
           <a:ln>
             <a:noFill/>
@@ -20604,7 +20604,7 @@
             </a:avLst>
           </a:prstGeom>
           <a:solidFill>
-            <a:srgbClr val="E5E4DF"/>
+            <a:srgbClr val="E3E3E1"/>
           </a:solidFill>
           <a:ln>
             <a:noFill/>
@@ -20650,7 +20650,7 @@
             </a:avLst>
           </a:prstGeom>
           <a:solidFill>
-            <a:srgbClr val="EDEDDD"/>
+            <a:srgbClr val="EFEFED"/>
           </a:solidFill>
           <a:ln>
             <a:noFill/>
@@ -20779,7 +20779,7 @@
             <a:avLst/>
           </a:prstGeom>
           <a:solidFill>
-            <a:srgbClr val="E5E4DF"/>
+            <a:srgbClr val="E3E3E1"/>
           </a:solidFill>
           <a:ln>
             <a:noFill/>
@@ -20864,7 +20864,7 @@
             </a:avLst>
           </a:prstGeom>
           <a:solidFill>
-            <a:srgbClr val="E5E4DF"/>
+            <a:srgbClr val="E3E3E1"/>
           </a:solidFill>
           <a:ln>
             <a:noFill/>
@@ -20910,7 +20910,7 @@
             </a:avLst>
           </a:prstGeom>
           <a:solidFill>
-            <a:srgbClr val="FFFFFF"/>
+            <a:srgbClr val="FAFAF9"/>
           </a:solidFill>
           <a:ln>
             <a:noFill/>
@@ -21055,7 +21055,7 @@
             <a:avLst/>
           </a:prstGeom>
           <a:solidFill>
-            <a:srgbClr val="E5E4DF"/>
+            <a:srgbClr val="E3E3E1"/>
           </a:solidFill>
           <a:ln>
             <a:noFill/>
@@ -21422,7 +21422,7 @@
     <p:bg>
       <p:bgPr>
         <a:solidFill>
-          <a:srgbClr val="F6F5F0"/>
+          <a:srgbClr val="FFFFFF"/>
         </a:solidFill>
         <a:effectLst/>
       </p:bgPr>
@@ -21631,7 +21631,7 @@
     <p:bg>
       <p:bgPr>
         <a:solidFill>
-          <a:srgbClr val="F8F7F2"/>
+          <a:srgbClr val="FFFFFF"/>
         </a:solidFill>
         <a:effectLst/>
       </p:bgPr>
@@ -21673,7 +21673,7 @@
             <a:r>
               <a:rPr sz="1700" b="1" i="0" spc="120">
                 <a:solidFill>
-                  <a:srgbClr val="B5B5AD"/>
+                  <a:srgbClr val="AEAEAA"/>
                 </a:solidFill>
                 <a:latin typeface="Outfit 1 Bold"/>
               </a:rPr>
@@ -21765,7 +21765,7 @@
             </a:avLst>
           </a:prstGeom>
           <a:solidFill>
-            <a:srgbClr val="E5E4DF"/>
+            <a:srgbClr val="E3E3E1"/>
           </a:solidFill>
           <a:ln>
             <a:noFill/>
@@ -21811,7 +21811,7 @@
             </a:avLst>
           </a:prstGeom>
           <a:solidFill>
-            <a:srgbClr val="FFFFFF"/>
+            <a:srgbClr val="FAFAF9"/>
           </a:solidFill>
           <a:ln>
             <a:noFill/>
@@ -21955,7 +21955,7 @@
             <a:r>
               <a:rPr sz="2400" b="0" i="0">
                 <a:solidFill>
-                  <a:srgbClr val="B5B5AD"/>
+                  <a:srgbClr val="AEAEAA"/>
                 </a:solidFill>
                 <a:latin typeface="Outfit 1"/>
               </a:rPr>
@@ -21981,7 +21981,7 @@
             </a:avLst>
           </a:prstGeom>
           <a:solidFill>
-            <a:srgbClr val="E5E4DF"/>
+            <a:srgbClr val="E3E3E1"/>
           </a:solidFill>
           <a:ln>
             <a:noFill/>
@@ -22027,7 +22027,7 @@
             </a:avLst>
           </a:prstGeom>
           <a:solidFill>
-            <a:srgbClr val="EDEDDD"/>
+            <a:srgbClr val="EFEFED"/>
           </a:solidFill>
           <a:ln>
             <a:noFill/>
@@ -22171,7 +22171,7 @@
             <a:r>
               <a:rPr sz="2400" b="0" i="0">
                 <a:solidFill>
-                  <a:srgbClr val="B5B5AD"/>
+                  <a:srgbClr val="AEAEAA"/>
                 </a:solidFill>
                 <a:latin typeface="Outfit 1"/>
               </a:rPr>
@@ -22197,7 +22197,7 @@
             </a:avLst>
           </a:prstGeom>
           <a:solidFill>
-            <a:srgbClr val="E5E4DF"/>
+            <a:srgbClr val="E3E3E1"/>
           </a:solidFill>
           <a:ln>
             <a:noFill/>
@@ -22243,7 +22243,7 @@
             </a:avLst>
           </a:prstGeom>
           <a:solidFill>
-            <a:srgbClr val="FFFFFF"/>
+            <a:srgbClr val="FAFAF9"/>
           </a:solidFill>
           <a:ln>
             <a:noFill/>
@@ -22387,7 +22387,7 @@
             <a:r>
               <a:rPr sz="2400" b="0" i="0">
                 <a:solidFill>
-                  <a:srgbClr val="B5B5AD"/>
+                  <a:srgbClr val="AEAEAA"/>
                 </a:solidFill>
                 <a:latin typeface="Outfit 1"/>
               </a:rPr>

</xml_diff>